<commit_message>
Package verified LaTeX reports, frontend exhibits and research results
</commit_message>
<xml_diff>
--- a/submission/AURORA_submission/AURORA_项目演示.pptx
+++ b/submission/AURORA_submission/AURORA_项目演示.pptx
@@ -1,6 +1,6 @@
 
 <file path=ppt/presentation.xml><?xml version="1.0" encoding="utf-8"?>
-<p:presentation xmlns:a="http://schemas.openxmlformats.org/drawingml/2006/main" xmlns:r="http://schemas.openxmlformats.org/officeDocument/2006/relationships" xmlns:p="http://schemas.openxmlformats.org/presentationml/2006/main" saveSubsetFonts="1" autoCompressPictures="0">
+<p:presentation xmlns:a="http://schemas.openxmlformats.org/drawingml/2006/main" xmlns:p="http://schemas.openxmlformats.org/presentationml/2006/main" xmlns:r="http://schemas.openxmlformats.org/officeDocument/2006/relationships" saveSubsetFonts="1" autoCompressPictures="0">
   <p:sldMasterIdLst>
     <p:sldMasterId id="2147483648" r:id="rId1"/>
   </p:sldMasterIdLst>
@@ -16,9 +16,14 @@
     <p:sldId id="264" r:id="rId16"/>
     <p:sldId id="265" r:id="rId17"/>
     <p:sldId id="266" r:id="rId18"/>
+    <p:sldId id="313" r:id="rIdExtra13"/>
+    <p:sldId id="314" r:id="rIdExtra14"/>
+    <p:sldId id="315" r:id="rIdExtra15"/>
+    <p:sldId id="316" r:id="rIdExtra16"/>
+    <p:sldId id="317" r:id="rIdExtra17"/>
     <p:sldId id="267" r:id="rId19"/>
   </p:sldIdLst>
-  <p:sldSz cx="12192000" cy="6858000" type="screen4x3"/>
+  <p:sldSz cx="12192000" cy="6858000" type="screen16x9"/>
   <p:notesSz cx="6858000" cy="9144000"/>
   <p:defaultTextStyle>
     <a:defPPr>
@@ -469,7 +474,7 @@
 </file>
 
 <file path=ppt/notesSlides/notesSlide1.xml><?xml version="1.0" encoding="utf-8"?>
-<p:notes xmlns:a="http://schemas.openxmlformats.org/drawingml/2006/main" xmlns:p="http://schemas.openxmlformats.org/presentationml/2006/main" xmlns:r="http://schemas.openxmlformats.org/officeDocument/2006/relationships">
+<p:notes xmlns:a="http://schemas.openxmlformats.org/drawingml/2006/main" xmlns:p="http://schemas.openxmlformats.org/presentationml/2006/main">
   <p:cSld>
     <p:spTree>
       <p:nvGrpSpPr>
@@ -518,7 +523,7 @@
           </a:p>
           <a:p>
             <a:r>
-              <a:t>沿用项目原始封面；其中 e 轨迹属于实验性诊断，正式判定采用独立确认流程。</a:t>
+              <a:t>封面由 LaTeX 重建；当前独立确认数为 0，e 轨迹仍为实验性诊断。</a:t>
             </a:r>
           </a:p>
           <a:p>
@@ -6565,6 +6570,256 @@
           </a:p>
         </p:txBody>
       </p:sp>
+    </p:spTree>
+  </p:cSld>
+  <p:clrMapOvr>
+    <a:masterClrMapping/>
+  </p:clrMapOvr>
+</p:sld>
+</file>
+
+<file path=ppt/slides/slide13.xml><?xml version="1.0" encoding="utf-8"?>
+<p:sld xmlns:a="http://schemas.openxmlformats.org/drawingml/2006/main" xmlns:p="http://schemas.openxmlformats.org/presentationml/2006/main" xmlns:r="http://schemas.openxmlformats.org/officeDocument/2006/relationships">
+  <p:cSld>
+    <p:bg>
+      <p:bgPr>
+        <a:solidFill>
+          <a:srgbClr val="102B30"/>
+        </a:solidFill>
+        <a:effectLst/>
+      </p:bgPr>
+    </p:bg>
+    <p:spTree>
+      <p:nvGrpSpPr>
+        <p:cNvPr id="1" name=""/>
+        <p:cNvGrpSpPr/>
+        <p:nvPr/>
+      </p:nvGrpSpPr>
+      <p:grpSpPr/>
+      <p:pic>
+        <p:nvPicPr>
+          <p:cNvPr id="2" name="Picture 1" descr="LaTeX rendered page 13"/>
+          <p:cNvPicPr>
+            <a:picLocks noChangeAspect="1"/>
+          </p:cNvPicPr>
+          <p:nvPr/>
+        </p:nvPicPr>
+        <p:blipFill>
+          <a:blip r:embed="rId3"/>
+          <a:stretch>
+            <a:fillRect/>
+          </a:stretch>
+        </p:blipFill>
+        <p:spPr>
+          <a:xfrm>
+            <a:off x="0" y="0"/>
+            <a:ext cx="12192000" cy="6858000"/>
+          </a:xfrm>
+          <a:prstGeom prst="rect">
+            <a:avLst/>
+          </a:prstGeom>
+        </p:spPr>
+      </p:pic>
+    </p:spTree>
+  </p:cSld>
+  <p:clrMapOvr>
+    <a:masterClrMapping/>
+  </p:clrMapOvr>
+</p:sld>
+</file>
+
+<file path=ppt/slides/slide14.xml><?xml version="1.0" encoding="utf-8"?>
+<p:sld xmlns:a="http://schemas.openxmlformats.org/drawingml/2006/main" xmlns:p="http://schemas.openxmlformats.org/presentationml/2006/main" xmlns:r="http://schemas.openxmlformats.org/officeDocument/2006/relationships">
+  <p:cSld>
+    <p:bg>
+      <p:bgPr>
+        <a:solidFill>
+          <a:srgbClr val="102B30"/>
+        </a:solidFill>
+        <a:effectLst/>
+      </p:bgPr>
+    </p:bg>
+    <p:spTree>
+      <p:nvGrpSpPr>
+        <p:cNvPr id="1" name=""/>
+        <p:cNvGrpSpPr/>
+        <p:nvPr/>
+      </p:nvGrpSpPr>
+      <p:grpSpPr/>
+      <p:pic>
+        <p:nvPicPr>
+          <p:cNvPr id="2" name="Picture 1" descr="LaTeX rendered page 14"/>
+          <p:cNvPicPr>
+            <a:picLocks noChangeAspect="1"/>
+          </p:cNvPicPr>
+          <p:nvPr/>
+        </p:nvPicPr>
+        <p:blipFill>
+          <a:blip r:embed="rId3"/>
+          <a:stretch>
+            <a:fillRect/>
+          </a:stretch>
+        </p:blipFill>
+        <p:spPr>
+          <a:xfrm>
+            <a:off x="0" y="0"/>
+            <a:ext cx="12192000" cy="6858000"/>
+          </a:xfrm>
+          <a:prstGeom prst="rect">
+            <a:avLst/>
+          </a:prstGeom>
+        </p:spPr>
+      </p:pic>
+    </p:spTree>
+  </p:cSld>
+  <p:clrMapOvr>
+    <a:masterClrMapping/>
+  </p:clrMapOvr>
+</p:sld>
+</file>
+
+<file path=ppt/slides/slide15.xml><?xml version="1.0" encoding="utf-8"?>
+<p:sld xmlns:a="http://schemas.openxmlformats.org/drawingml/2006/main" xmlns:p="http://schemas.openxmlformats.org/presentationml/2006/main" xmlns:r="http://schemas.openxmlformats.org/officeDocument/2006/relationships">
+  <p:cSld>
+    <p:bg>
+      <p:bgPr>
+        <a:solidFill>
+          <a:srgbClr val="102B30"/>
+        </a:solidFill>
+        <a:effectLst/>
+      </p:bgPr>
+    </p:bg>
+    <p:spTree>
+      <p:nvGrpSpPr>
+        <p:cNvPr id="1" name=""/>
+        <p:cNvGrpSpPr/>
+        <p:nvPr/>
+      </p:nvGrpSpPr>
+      <p:grpSpPr/>
+      <p:pic>
+        <p:nvPicPr>
+          <p:cNvPr id="2" name="Picture 1" descr="LaTeX rendered page 15"/>
+          <p:cNvPicPr>
+            <a:picLocks noChangeAspect="1"/>
+          </p:cNvPicPr>
+          <p:nvPr/>
+        </p:nvPicPr>
+        <p:blipFill>
+          <a:blip r:embed="rId3"/>
+          <a:stretch>
+            <a:fillRect/>
+          </a:stretch>
+        </p:blipFill>
+        <p:spPr>
+          <a:xfrm>
+            <a:off x="0" y="0"/>
+            <a:ext cx="12192000" cy="6858000"/>
+          </a:xfrm>
+          <a:prstGeom prst="rect">
+            <a:avLst/>
+          </a:prstGeom>
+        </p:spPr>
+      </p:pic>
+    </p:spTree>
+  </p:cSld>
+  <p:clrMapOvr>
+    <a:masterClrMapping/>
+  </p:clrMapOvr>
+</p:sld>
+</file>
+
+<file path=ppt/slides/slide16.xml><?xml version="1.0" encoding="utf-8"?>
+<p:sld xmlns:a="http://schemas.openxmlformats.org/drawingml/2006/main" xmlns:p="http://schemas.openxmlformats.org/presentationml/2006/main" xmlns:r="http://schemas.openxmlformats.org/officeDocument/2006/relationships">
+  <p:cSld>
+    <p:bg>
+      <p:bgPr>
+        <a:solidFill>
+          <a:srgbClr val="102B30"/>
+        </a:solidFill>
+        <a:effectLst/>
+      </p:bgPr>
+    </p:bg>
+    <p:spTree>
+      <p:nvGrpSpPr>
+        <p:cNvPr id="1" name=""/>
+        <p:cNvGrpSpPr/>
+        <p:nvPr/>
+      </p:nvGrpSpPr>
+      <p:grpSpPr/>
+      <p:pic>
+        <p:nvPicPr>
+          <p:cNvPr id="2" name="Picture 1" descr="LaTeX rendered page 16"/>
+          <p:cNvPicPr>
+            <a:picLocks noChangeAspect="1"/>
+          </p:cNvPicPr>
+          <p:nvPr/>
+        </p:nvPicPr>
+        <p:blipFill>
+          <a:blip r:embed="rId3"/>
+          <a:stretch>
+            <a:fillRect/>
+          </a:stretch>
+        </p:blipFill>
+        <p:spPr>
+          <a:xfrm>
+            <a:off x="0" y="0"/>
+            <a:ext cx="12192000" cy="6858000"/>
+          </a:xfrm>
+          <a:prstGeom prst="rect">
+            <a:avLst/>
+          </a:prstGeom>
+        </p:spPr>
+      </p:pic>
+    </p:spTree>
+  </p:cSld>
+  <p:clrMapOvr>
+    <a:masterClrMapping/>
+  </p:clrMapOvr>
+</p:sld>
+</file>
+
+<file path=ppt/slides/slide17.xml><?xml version="1.0" encoding="utf-8"?>
+<p:sld xmlns:a="http://schemas.openxmlformats.org/drawingml/2006/main" xmlns:p="http://schemas.openxmlformats.org/presentationml/2006/main" xmlns:r="http://schemas.openxmlformats.org/officeDocument/2006/relationships">
+  <p:cSld>
+    <p:bg>
+      <p:bgPr>
+        <a:solidFill>
+          <a:srgbClr val="102B30"/>
+        </a:solidFill>
+        <a:effectLst/>
+      </p:bgPr>
+    </p:bg>
+    <p:spTree>
+      <p:nvGrpSpPr>
+        <p:cNvPr id="1" name=""/>
+        <p:cNvGrpSpPr/>
+        <p:nvPr/>
+      </p:nvGrpSpPr>
+      <p:grpSpPr/>
+      <p:pic>
+        <p:nvPicPr>
+          <p:cNvPr id="2" name="Picture 1" descr="LaTeX rendered page 17"/>
+          <p:cNvPicPr>
+            <a:picLocks noChangeAspect="1"/>
+          </p:cNvPicPr>
+          <p:nvPr/>
+        </p:nvPicPr>
+        <p:blipFill>
+          <a:blip r:embed="rId3"/>
+          <a:stretch>
+            <a:fillRect/>
+          </a:stretch>
+        </p:blipFill>
+        <p:spPr>
+          <a:xfrm>
+            <a:off x="0" y="0"/>
+            <a:ext cx="12192000" cy="6858000"/>
+          </a:xfrm>
+          <a:prstGeom prst="rect">
+            <a:avLst/>
+          </a:prstGeom>
+        </p:spPr>
+      </p:pic>
     </p:spTree>
   </p:cSld>
   <p:clrMapOvr>

</xml_diff>